<commit_message>
Deck: plainer wording in slides and speaker notes
Co-Authored-By: Claude Opus 5.5 <noreply@anthropic.com>
</commit_message>
<xml_diff>
--- a/docs/presentation/QuickLift-Week7-PoC.pptx
+++ b/docs/presentation/QuickLift-Week7-PoC.pptx
@@ -829,7 +829,7 @@
           <a:lstStyle/>
           <a:p>
             <a:r>
-              <a:t>Say the team and the product name: QuickLift, an AI agent that fixes what stops Australian shoppers buying on small Shopify stores. Then go straight to the problem.</a:t>
+              <a:t>Say who we are and the product name. QuickLift helps small Australian Shopify stores fix the things that stop people buying. Don't stay on this slide long.</a:t>
             </a:r>
           </a:p>
         </p:txBody>
@@ -915,7 +915,7 @@
           <a:lstStyle/>
           <a:p>
             <a:r>
-              <a:t>About 40 seconds. One sentence: small Australian Shopify stores lose sales to small gaps, and the owner can't tell which matter or fix them without a developer. Strongest evidence first: our owner's own words. Then Baymard on surprise costs, and that even a big brand like Frank Body misses basics.</a:t>
+              <a:t>Around 40 seconds. Start with the problem in one line, then the owner's quote, since that's our strongest evidence. Baymard backs up the point about surprise costs at checkout, and the Frank Body example shows even a big store misses this stuff.</a:t>
             </a:r>
           </a:p>
         </p:txBody>
@@ -985,7 +985,7 @@
           <a:lstStyle/>
           <a:p>
             <a:r>
-              <a:t>About 50 seconds. This is the owner's dashboard: what to fix first, and the agent. Decision 1: Shopify only, because every Shopify store publishes its pages and products, so we can check any store with no install; conversion works the same across ecommerce, so we didn't narrow to one category. Decision 2: the owner always sees the change on their own page first; our Week 2 research said trust is the barrier. Decision 3: it never invents facts, so we deliberately don't add reviews automatically.</a:t>
+              <a:t>Around 50 seconds. This is the dashboard the owner sees. We only do Shopify because every store publishes its pages and products, which means we can check a store without installing anything. We didn't narrow it to one type of shop because the same problems turn up across ecommerce. Owners see changes on their own page first, because our Week 2 research said trust was the big barrier. And we don't make up facts, which is why there's no automatic reviews fix.</a:t>
             </a:r>
           </a:p>
         </p:txBody>
@@ -1055,7 +1055,7 @@
           <a:lstStyle/>
           <a:p>
             <a:r>
-              <a:t>About 60 seconds, the heart of it. Today: to change anything on a Shopify page the owner has to find the right theme file and write code, or pay a developer. With QuickLift: they type the change in plain words. The agent reads that exact page, writes the code against the store's own theme, and shows it on the real page. The owner checks it, including any fact the agent flags, like a shipping time it can't know, and presses Approve. That's the work it takes off their plate.</a:t>
+              <a:t>Around a minute. This is the main part. Right now, changing anything on a Shopify page means finding the right theme file and writing code, or paying someone. With QuickLift the owner just types what they want. The agent reads that page, writes the code for that store's theme and shows the result on the real page. The owner checks it, including anything the agent flags, like a shipping time it can't know, and then approves it.</a:t>
             </a:r>
           </a:p>
         </p:txBody>
@@ -1125,7 +1125,7 @@
           <a:lstStyle/>
           <a:p>
             <a:r>
-              <a:t>About 30 seconds. A web app on Node and Express with Claude as the agent. No database: each check reads the store's public pages live. Be honest: there's no log-in yet, and publishing is set up for one store we hold a key for. PROMPTS.md is in the repo.</a:t>
+              <a:t>Around 30 seconds. It's a Node and Express web app, with Claude doing the agent work. There's no database, each check reads the store live. Be upfront that there's no log-in yet and that publishing only works on a store we have a key for. PROMPTS.md is in the repo.</a:t>
             </a:r>
           </a:p>
         </p:txBody>
@@ -1195,7 +1195,7 @@
           <a:lstStyle/>
           <a:p>
             <a:r>
-              <a:t>About 4 minutes. Use the demo bar at the top (keys 1, 2, 3) to move between home, dashboard and preview. Check frankbody.com once before presenting so it loads instantly. If something fails, say so and go to the backup slide or the recording.</a:t>
+              <a:t>About 4 minutes. Use the demo bar at the top, or keys 1, 2 and 3, to jump between pages. Load frankbody.com once before we present so it's quick. If something breaks, say so and switch to the backup slide or the recording.</a:t>
             </a:r>
           </a:p>
         </p:txBody>
@@ -1265,7 +1265,7 @@
           <a:lstStyle/>
           <a:p>
             <a:r>
-              <a:t>Only if the live demo fails. There's also a screen recording of the full demo.</a:t>
+              <a:t>Only use this if the live demo fails. We also have a recording of the whole demo.</a:t>
             </a:r>
           </a:p>
         </p:txBody>
@@ -1335,7 +1335,7 @@
           <a:lstStyle/>
           <a:p>
             <a:r>
-              <a:t>Leave this up for questions.</a:t>
+              <a:t>Leave this up during questions.</a:t>
             </a:r>
           </a:p>
         </p:txBody>
@@ -11304,7 +11304,7 @@
                 </a:solidFill>
                 <a:latin typeface="Arial"/>
               </a:rPr>
-              <a:t>Small Australian Shopify stores lose sales to gaps a shopper notices in seconds: no Afterpay next to the price, delivery costs hidden until checkout, nothing saying the business is local. Owners can’t tell which gaps matter most, and most can’t edit their theme without paying a developer. So the gaps stay.</a:t>
+              <a:t>Small Australian Shopify stores lose sales over things a shopper spots in seconds, like no Afterpay near the price or a delivery cost that only shows up at checkout. Owners usually can't tell which of these matter most. Even when they can, most can't change their theme without paying a developer, so nothing gets fixed.</a:t>
             </a:r>
           </a:p>
         </p:txBody>
@@ -11359,7 +11359,7 @@
                 </a:solidFill>
                 <a:latin typeface="Arial"/>
               </a:rPr>
-              <a:t>Founders of small Australian Shopify stores, with no developer and little time</a:t>
+              <a:t>People running small Australian Shopify stores, usually without a developer and short on time</a:t>
             </a:r>
           </a:p>
         </p:txBody>
@@ -11497,7 +11497,7 @@
                 </a:solidFill>
                 <a:latin typeface="Arial"/>
               </a:rPr>
-              <a:t>Unexpected extra costs at checkout, like shipping, are among the top reasons shoppers abandon a cart.</a:t>
+              <a:t>Extra costs at checkout, like shipping, are one of the most common reasons people abandon a cart.</a:t>
             </a:r>
           </a:p>
         </p:txBody>
@@ -11683,7 +11683,7 @@
                 </a:solidFill>
                 <a:latin typeface="Arial"/>
               </a:rPr>
-              <a:t>Even big brands miss basics: our check of frankbody.com found no Afterpay by the price and no local-business signal.</a:t>
+              <a:t>Big brands miss these too. When we checked frankbody.com it had no Afterpay near the price and nothing saying it's Australian.</a:t>
             </a:r>
           </a:p>
         </p:txBody>
@@ -11731,7 +11731,7 @@
                 </a:solidFill>
                 <a:latin typeface="Arial"/>
               </a:rPr>
-              <a:t>Our own QuickLift check, 27 Oct 2026</a:t>
+              <a:t>Our own check with QuickLift, 27 Oct 2026</a:t>
             </a:r>
           </a:p>
         </p:txBody>
@@ -12140,7 +12140,7 @@
                 </a:solidFill>
                 <a:latin typeface="Arial"/>
               </a:rPr>
-              <a:t>Paste in a Shopify store: QuickLift ranks what shoppers would miss, shows each fix on the real page, and its AI agent makes any change the owner asks for.</a:t>
+              <a:t>You paste in a Shopify store and QuickLift lists what a shopper would miss. The owner can try each fix on their real page, or ask the agent for a change of their own.</a:t>
             </a:r>
           </a:p>
         </p:txBody>
@@ -12328,7 +12328,7 @@
                 </a:solidFill>
                 <a:latin typeface="Arial"/>
               </a:rPr>
-              <a:t>Shopify stores only, across all of ecommerce</a:t>
+              <a:t>Only Shopify stores, but any kind of online shop</a:t>
             </a:r>
           </a:p>
         </p:txBody>
@@ -12406,7 +12406,7 @@
                 </a:solidFill>
                 <a:latin typeface="Arial"/>
               </a:rPr>
-              <a:t>Every Shopify store publishes its pages and product data, so we can check any store with no login</a:t>
+              <a:t>Shopify stores publish their pages and product data, so we can check one without a login</a:t>
             </a:r>
           </a:p>
         </p:txBody>
@@ -12526,7 +12526,7 @@
                 </a:solidFill>
                 <a:latin typeface="Arial"/>
               </a:rPr>
-              <a:t>Show every change on a copy of the real page before it goes live</a:t>
+              <a:t>Owners see every change on their own page before it goes live</a:t>
             </a:r>
           </a:p>
         </p:txBody>
@@ -12604,7 +12604,7 @@
                 </a:solidFill>
                 <a:latin typeface="Arial"/>
               </a:rPr>
-              <a:t>Week 2: trust, not cost, is SMEs’ main barrier to AI. Owners trust what they see on their own page</a:t>
+              <a:t>Our Week 2 research found trust was a bigger barrier to SMEs using AI than cost</a:t>
             </a:r>
           </a:p>
         </p:txBody>
@@ -12724,7 +12724,7 @@
                 </a:solidFill>
                 <a:latin typeface="Arial"/>
               </a:rPr>
-              <a:t>Never invent facts. We chose not to auto-add reviews</a:t>
+              <a:t>We don't make up facts, so there's no automatic reviews fix</a:t>
             </a:r>
           </a:p>
         </p:txBody>
@@ -12802,7 +12802,7 @@
                 </a:solidFill>
                 <a:latin typeface="Arial"/>
               </a:rPr>
-              <a:t>Fake reviews or timers mislead shoppers. The agent flags any fact only the owner can confirm</a:t>
+              <a:t>Fake reviews mislead shoppers and break consumer law. The agent flags facts the owner must confirm</a:t>
             </a:r>
           </a:p>
         </p:txBody>
@@ -12953,7 +12953,7 @@
                 </a:solidFill>
                 <a:latin typeface="Arial"/>
               </a:rPr>
-              <a:t>changing anything on a Shopify page means editing theme code, or paying a developer</a:t>
+              <a:t>any change to a Shopify page means editing theme code or paying someone to do it</a:t>
             </a:r>
           </a:p>
         </p:txBody>
@@ -13073,7 +13073,7 @@
                 </a:solidFill>
                 <a:latin typeface="Arial"/>
               </a:rPr>
-              <a:t>Work out which theme file controls it</a:t>
+              <a:t>Find the theme file that controls it</a:t>
             </a:r>
           </a:p>
         </p:txBody>
@@ -13235,7 +13235,7 @@
                 </a:solidFill>
                 <a:latin typeface="Arial"/>
               </a:rPr>
-              <a:t>Or brief and pay a developer, then wait</a:t>
+              <a:t>Or pay a developer and wait</a:t>
             </a:r>
           </a:p>
         </p:txBody>
@@ -13439,7 +13439,7 @@
                 </a:solidFill>
                 <a:latin typeface="Arial"/>
               </a:rPr>
-              <a:t>The owner types a change in plain words, or switches on a suggested fix</a:t>
+              <a:t>The owner types what they want changed, or turns on a suggested fix</a:t>
             </a:r>
           </a:p>
         </p:txBody>
@@ -13561,7 +13561,7 @@
                 </a:solidFill>
                 <a:latin typeface="Arial"/>
               </a:rPr>
-              <a:t>Reads the live page, picks the elements, writes the code for that theme</a:t>
+              <a:t>Works out which parts of the page to change and writes the code for that theme</a:t>
             </a:r>
           </a:p>
         </p:txBody>
@@ -13683,7 +13683,7 @@
                 </a:solidFill>
                 <a:latin typeface="Arial"/>
               </a:rPr>
-              <a:t>Sees it on the real page, reads any warning, then presses Approve</a:t>
+              <a:t>The owner checks it on their real page, reads any warning, and approves it</a:t>
             </a:r>
           </a:p>
         </p:txBody>
@@ -13805,7 +13805,7 @@
                 </a:solidFill>
                 <a:latin typeface="Arial"/>
               </a:rPr>
-              <a:t>A store change in minutes, no code or developer, one-click undo</a:t>
+              <a:t>The change is made in minutes without the owner touching code, and can be undone</a:t>
             </a:r>
           </a:p>
         </p:txBody>
@@ -13925,7 +13925,7 @@
                 </a:solidFill>
                 <a:latin typeface="Arial"/>
               </a:rPr>
-              <a:t>It acts, not only answers. It reads an outline of the store’s live page, decides which elements to change and writes the CSS and JavaScript with Claude (Anthropic API, fixed reply format). It applies the change to a sealed preview, flags anything it had to assume, like a shipping time, and on approval publishes it into the theme through Shopify’s Admin API.</a:t>
+              <a:t>It makes the edit itself instead of telling the owner how. It reads an outline of the live page, decides what to change and writes the CSS and JavaScript using Claude through the Anthropic API. The change shows up in a preview first, and if the agent had to assume something, like a shipping time, it says so. Once the owner approves, it goes into the theme through Shopify's Admin API.</a:t>
             </a:r>
           </a:p>
         </p:txBody>
@@ -14148,7 +14148,7 @@
                 </a:solidFill>
                 <a:latin typeface="Arial"/>
               </a:rPr>
-              <a:t>Web app: home page, owner’s dashboard, and a preview of the store’s real page with Approve and publish</a:t>
+              <a:t>A web app with a home page, the owner's dashboard and a preview of their real store page</a:t>
             </a:r>
           </a:p>
         </p:txBody>
@@ -14268,7 +14268,7 @@
                 </a:solidFill>
                 <a:latin typeface="Arial"/>
               </a:rPr>
-              <a:t>No database. Reads each store’s public pages and product feed live, cached for 5 minutes. Stores nothing about shoppers.</a:t>
+              <a:t>There's no database yet. Each check reads the store's public pages and product feed live and keeps them for five minutes. We don't store anything about shoppers.</a:t>
             </a:r>
           </a:p>
         </p:txBody>
@@ -14388,7 +14388,7 @@
                 </a:solidFill>
                 <a:latin typeface="Arial"/>
               </a:rPr>
-              <a:t>Claude via the Anthropic API, called from our Node and Express server, so the key never reaches the browser</a:t>
+              <a:t>Claude, through the Anthropic API. Our Node and Express server makes the call, so the API key never reaches the browser.</a:t>
             </a:r>
           </a:p>
         </p:txBody>
@@ -14508,7 +14508,7 @@
                 </a:solidFill>
                 <a:latin typeface="Arial"/>
               </a:rPr>
-              <a:t>Shopify storefront pages and product feed (public, read-only); Shopify Admin API to publish</a:t>
+              <a:t>Shopify's public storefront pages and product feed for reading, and the Shopify Admin API for publishing</a:t>
             </a:r>
           </a:p>
         </p:txBody>
@@ -14628,7 +14628,7 @@
                 </a:solidFill>
                 <a:latin typeface="Arial"/>
               </a:rPr>
-              <a:t>Check any Shopify store: 7 checks, ranked dashboard, 4 ready-made fixes, agent changes in a live preview, 16 automated tests</a:t>
+              <a:t>Checking any Shopify store against 7 checks, the ranked dashboard, 4 ready-made fixes, agent changes in the preview, and 16 automated tests</a:t>
             </a:r>
           </a:p>
         </p:txBody>
@@ -14706,7 +14706,7 @@
                 </a:solidFill>
                 <a:latin typeface="Arial"/>
               </a:rPr>
-              <a:t>No log-in yet: the dashboard opens for any store address. Publishing works only on a store we hold a key for [not yet run on our dev store]. Weeks 8–9: connect stores through Shopify, test with our owner.</a:t>
+              <a:t>There's no log-in, so the dashboard opens for any store address. Publishing only works on a store we have a key for [not yet tried on our dev store]. In Weeks 8 and 9 we'll connect stores through Shopify and test with our owner.</a:t>
             </a:r>
           </a:p>
         </p:txBody>
@@ -15083,7 +15083,7 @@
                 </a:solidFill>
                 <a:latin typeface="Arial"/>
               </a:rPr>
-              <a:t>They want more shoppers to buy, but can’t tell what to change and can’t edit code. We use frankbody.com, a real Australian store.</a:t>
+              <a:t>They want more people to buy but don't know what to change, and they can't code. We're using frankbody.com, a real Australian store, as the example.</a:t>
             </a:r>
           </a:p>
           <a:p>
@@ -15108,7 +15108,7 @@
                 </a:solidFill>
                 <a:latin typeface="Arial"/>
               </a:rPr>
-              <a:t>Step 3: the agent changes the live page from one plain sentence</a:t>
+              <a:t>the agent changing the live page from one sentence in step 3</a:t>
             </a:r>
           </a:p>
         </p:txBody>
@@ -15285,7 +15285,7 @@
                 </a:solidFill>
                 <a:latin typeface="Arial"/>
               </a:rPr>
-              <a:t>Home page: enter frankbody.com. The dashboard ranks three things to fix, each with its reason</a:t>
+              <a:t>Enter frankbody.com on the home page. The dashboard lists three things to fix and says why</a:t>
             </a:r>
           </a:p>
         </p:txBody>
@@ -15423,7 +15423,7 @@
                 </a:solidFill>
                 <a:latin typeface="Arial"/>
               </a:rPr>
-              <a:t>Preview the Afterpay fix: it appears under the real price. Flip Before / After</a:t>
+              <a:t>Preview the Afterpay fix, which shows up under the real price, then flip between Before and After</a:t>
             </a:r>
           </a:p>
         </p:txBody>
@@ -15561,7 +15561,7 @@
                 </a:solidFill>
                 <a:latin typeface="Arial"/>
               </a:rPr>
-              <a:t>Ask the agent: “Make Add to cart bigger and bright green, and add ‘Ships from Sydney in 1–2 days’”</a:t>
+              <a:t>Ask the agent to make Add to cart bigger and bright green, with a line saying it ships from Sydney in 1 to 2 days</a:t>
             </a:r>
           </a:p>
         </p:txBody>
@@ -15699,7 +15699,7 @@
                 </a:solidFill>
                 <a:latin typeface="Arial"/>
               </a:rPr>
-              <a:t>It changes the page and flags the shipping claim for the owner to check. Press Approve and publish</a:t>
+              <a:t>Show that it flags the shipping time for the owner to check, then press Approve and publish</a:t>
             </a:r>
           </a:p>
         </p:txBody>
@@ -15870,7 +15870,7 @@
                 </a:solidFill>
                 <a:latin typeface="Arial"/>
               </a:rPr>
-              <a:t>The owner’s dashboard: three things to fix on frankbody.com, most important first</a:t>
+              <a:t>The dashboard for frankbody.com, with the three things to fix in order</a:t>
             </a:r>
           </a:p>
         </p:txBody>
@@ -15938,7 +15938,7 @@
                 </a:solidFill>
                 <a:latin typeface="Arial"/>
               </a:rPr>
-              <a:t>A ready-made fix on the real page: Afterpay instalments under the price</a:t>
+              <a:t>The Afterpay fix on the real product page, sitting under the price</a:t>
             </a:r>
           </a:p>
         </p:txBody>
@@ -16006,7 +16006,7 @@
                 </a:solidFill>
                 <a:latin typeface="Arial"/>
               </a:rPr>
-              <a:t>The agent’s change: a bigger green button and a shipping line, flagged for the owner to confirm</a:t>
+              <a:t>After the agent's change, with its note asking the owner to confirm the shipping time</a:t>
             </a:r>
           </a:p>
         </p:txBody>
@@ -16349,7 +16349,7 @@
                 </a:solidFill>
                 <a:latin typeface="Arial"/>
               </a:rPr>
-              <a:t>Our participating Shopify owner, on their own store</a:t>
+              <a:t>Our participating Shopify owner, using their own store</a:t>
             </a:r>
           </a:p>
           <a:p>
@@ -16365,7 +16365,7 @@
                 </a:solidFill>
                 <a:latin typeface="Arial"/>
               </a:rPr>
-              <a:t>Check their store, switch on the fixes they agree with, and ask the agent for one change of their own</a:t>
+              <a:t>We'll ask them to check their store, turn on any fixes they agree with, and ask the agent for one change of their own</a:t>
             </a:r>
           </a:p>
           <a:p>
@@ -16381,7 +16381,7 @@
                 </a:solidFill>
                 <a:latin typeface="Arial"/>
               </a:rPr>
-              <a:t>They’d approve a change they would otherwise have paid a developer for, and come back for the next one</a:t>
+              <a:t>If they'd approve a change they'd normally pay a developer for, and want to come back and make another, it's working</a:t>
             </a:r>
           </a:p>
         </p:txBody>

</xml_diff>

<commit_message>
Deck and recording: in-place changes and the agent's ideas
Co-Authored-By: Claude Opus 5.5 <noreply@anthropic.com>
</commit_message>
<xml_diff>
--- a/docs/presentation/QuickLift-Week7-PoC.pptx
+++ b/docs/presentation/QuickLift-Week7-PoC.pptx
@@ -1055,7 +1055,7 @@
           <a:lstStyle/>
           <a:p>
             <a:r>
-              <a:t>Around a minute. This is the main part. Right now, changing anything on a Shopify page means finding the right theme file and writing code, or paying someone. With QuickLift the owner just types what they want. The agent reads that page, writes the code for that store's theme and shows the result on the real page. The owner checks it, including anything the agent flags, like a shipping time it can't know, and then approves it.</a:t>
+              <a:t>Around a minute. This is the main part. Right now, changing anything on a Shopify page means finding the right theme file and writing code, or paying someone. With QuickLift the owner just types what they want, or picks one of the ideas the agent comes up with for that page. The agent reads the page, writes the code for that store's theme and adds the change to the real page, marked so it's easy to spot. The owner checks it, including anything the agent flags, like a shipping time it can't know, and then approves it.</a:t>
             </a:r>
           </a:p>
         </p:txBody>
@@ -1195,7 +1195,7 @@
           <a:lstStyle/>
           <a:p>
             <a:r>
-              <a:t>About 4 minutes. Use the demo bar at the top, or keys 1, 2 and 3, to jump between pages. Load frankbody.com once before we present so it's quick. If something breaks, say so and switch to the backup slide or the recording.</a:t>
+              <a:t>About 4 minutes. Use the demo bar at the top, or keys 1, 2 and 3, to jump between pages. Open frankbody.com once before we present so the page and the agent's ideas are already loaded. If something breaks, say so and switch to the backup slide or the recording.</a:t>
             </a:r>
           </a:p>
         </p:txBody>
@@ -13439,7 +13439,7 @@
                 </a:solidFill>
                 <a:latin typeface="Arial"/>
               </a:rPr>
-              <a:t>The owner types what they want changed, or turns on a suggested fix</a:t>
+              <a:t>The owner types what they want changed, or picks one of the agent's ideas for the page</a:t>
             </a:r>
           </a:p>
         </p:txBody>
@@ -14628,7 +14628,7 @@
                 </a:solidFill>
                 <a:latin typeface="Arial"/>
               </a:rPr>
-              <a:t>Checking any Shopify store against 7 checks, the ranked dashboard, 4 ready-made fixes, agent changes in the preview, and 16 automated tests</a:t>
+              <a:t>Checking any Shopify store, the ranked dashboard, 4 ready-made fixes, the agent's own ideas for each page, its changes on the real page, and 16 automated tests</a:t>
             </a:r>
           </a:p>
         </p:txBody>
@@ -15423,7 +15423,7 @@
                 </a:solidFill>
                 <a:latin typeface="Arial"/>
               </a:rPr>
-              <a:t>Preview the Afterpay fix, which shows up under the real price, then flip between Before and After</a:t>
+              <a:t>Turn on the Afterpay fix. The page jumps to it under the real price, marked as changed</a:t>
             </a:r>
           </a:p>
         </p:txBody>
@@ -15561,7 +15561,7 @@
                 </a:solidFill>
                 <a:latin typeface="Arial"/>
               </a:rPr>
-              <a:t>Ask the agent to make Add to cart bigger and bright green, with a line saying it ships from Sydney in 1 to 2 days</a:t>
+              <a:t>Try one of the agent's ideas, then ask it to make Add to cart bigger and green with a Sydney shipping line</a:t>
             </a:r>
           </a:p>
         </p:txBody>
@@ -15877,7 +15877,7 @@
       </p:sp>
       <p:pic>
         <p:nvPicPr>
-          <p:cNvPr id="6" name="Rectangle 5 picture" descr="Preview with Afterpay instalments under the price"/>
+          <p:cNvPr id="6" name="Rectangle 5 picture" descr="Preview with the agent's ideas and the kit contents list it added"/>
           <p:cNvPicPr>
             <a:picLocks noChangeAspect="1"/>
           </p:cNvPicPr>
@@ -15938,7 +15938,7 @@
                 </a:solidFill>
                 <a:latin typeface="Arial"/>
               </a:rPr>
-              <a:t>The Afterpay fix on the real product page, sitting under the price</a:t>
+              <a:t>One of the agent's own ideas, tried on the real page: a list of what's in the kit</a:t>
             </a:r>
           </a:p>
         </p:txBody>

</xml_diff>